<commit_message>
docs(weekly_report): 2026-06-04 — box/crosshair removal + S-only localization eval
- New weekly_report_2026-06-04.html (period 05-29~06-04): white-box removal
  (rcp template, photometric 1/6->6/6), crosshair removal (msr frame, inpaint +
  double-verify), 2x2 ablation, and S-only golden localization eval (office-pending).
- Update generate_status_report.py step data to current align-point accuracy focus;
  regenerate workflow_2_status_report.html + .pptx (date -> 2026-06-04).

Co-Authored-By: Claude Opus 4.8 (1M context) <noreply@anthropic.com>
</commit_message>
<xml_diff>
--- a/poc/workflow_2/docs/weekly_report/workflow_2_status_report.pptx
+++ b/poc/workflow_2/docs/weekly_report/workflow_2_status_report.pptx
@@ -3156,7 +3156,7 @@
                 </a:solidFill>
                 <a:latin typeface="Malgun Gothic"/>
               </a:rPr>
-              <a:t>SEM Monitor 조작 + Align Key 검색 자동화</a:t>
+              <a:t>Align Point 보정 정확도 — 표식 제거 + 검증</a:t>
             </a:r>
           </a:p>
         </p:txBody>
@@ -3191,7 +3191,7 @@
                 </a:solidFill>
                 <a:latin typeface="Malgun Gothic"/>
               </a:rPr>
-              <a:t>작성일 2026-05-14  ·  범위 poc/workflow_2/</a:t>
+              <a:t>작성일 2026-06-04  ·  범위 poc/workflow_2/</a:t>
             </a:r>
           </a:p>
         </p:txBody>
@@ -3796,7 +3796,7 @@
                 </a:solidFill>
                 <a:latin typeface="Malgun Gothic"/>
               </a:rPr>
-              <a:t>Frame 변화 필터링 (CV)</a:t>
+              <a:t>SEM 화면 영역 검출</a:t>
             </a:r>
           </a:p>
           <a:p>
@@ -3808,7 +3808,7 @@
                 </a:solidFill>
                 <a:latin typeface="Malgun Gothic"/>
               </a:rPr>
-              <a:t>cv2.absdiff·dilate·connectedComponents로 정적 프레임 제거, VLM 입력량 축소</a:t>
+              <a:t>모든 탐색의 기준점인 live SEM 박스를 검출, 장비별 기준 위치 저장</a:t>
             </a:r>
           </a:p>
         </p:txBody>
@@ -3910,7 +3910,7 @@
                 </a:solidFill>
                 <a:latin typeface="Malgun Gothic"/>
               </a:rPr>
-              <a:t>SEM Monitor Box 인식</a:t>
+              <a:t>OK 버튼 검출·클릭</a:t>
             </a:r>
           </a:p>
           <a:p>
@@ -3922,7 +3922,7 @@
                 </a:solidFill>
                 <a:latin typeface="Malgun Gothic"/>
               </a:rPr>
-              <a:t>VLM이 live SEM 영역 bbox를 식별 (제어 패널 가림에도 정상 동작)</a:t>
+              <a:t>보정을 확정하는 마지막 동작, OCR 재확인으로 오클릭 차단</a:t>
             </a:r>
           </a:p>
         </p:txBody>
@@ -3971,6 +3971,234 @@
         <p:spPr>
           <a:xfrm>
             <a:off x="4251960" y="3291840"/>
+            <a:ext cx="1760220" cy="2194560"/>
+          </a:xfrm>
+          <a:prstGeom prst="roundRect">
+            <a:avLst/>
+          </a:prstGeom>
+          <a:solidFill>
+            <a:srgbClr val="E8F5E9"/>
+          </a:solidFill>
+          <a:ln w="25400">
+            <a:solidFill>
+              <a:srgbClr val="2E7D32"/>
+            </a:solidFill>
+          </a:ln>
+          <a:effectLst/>
+        </p:spPr>
+        <p:style>
+          <a:lnRef idx="1">
+            <a:schemeClr val="accent1"/>
+          </a:lnRef>
+          <a:fillRef idx="3">
+            <a:schemeClr val="accent1"/>
+          </a:fillRef>
+          <a:effectRef idx="2">
+            <a:schemeClr val="accent1"/>
+          </a:effectRef>
+          <a:fontRef idx="minor">
+            <a:schemeClr val="lt1"/>
+          </a:fontRef>
+        </p:style>
+        <p:txBody>
+          <a:bodyPr rtlCol="0" anchor="ctr" wrap="square" tIns="73152" bIns="73152"/>
+          <a:lstStyle/>
+          <a:p>
+            <a:pPr algn="ctr"/>
+            <a:r>
+              <a:rPr sz="900" b="1">
+                <a:solidFill>
+                  <a:srgbClr val="1B5E20"/>
+                </a:solidFill>
+                <a:latin typeface="Malgun Gothic"/>
+              </a:rPr>
+              <a:t>✅ 완료</a:t>
+            </a:r>
+          </a:p>
+          <a:p>
+            <a:pPr algn="ctr"/>
+            <a:r>
+              <a:rPr sz="1100" b="1">
+                <a:solidFill>
+                  <a:srgbClr val="1B5E20"/>
+                </a:solidFill>
+                <a:latin typeface="Malgun Gothic"/>
+              </a:rPr>
+              <a:t>흰 박스 제거 (template)</a:t>
+            </a:r>
+          </a:p>
+          <a:p>
+            <a:pPr algn="ctr"/>
+            <a:r>
+              <a:rPr sz="800" b="0">
+                <a:solidFill>
+                  <a:srgbClr val="1B5E20"/>
+                </a:solidFill>
+                <a:latin typeface="Malgun Gothic"/>
+              </a:rPr>
+              <a:t>고정 디지털값(히스토그램 섬) photometric 검출로 박스 안쪽만 crop, 최악 샘플 1/6→6/6 (합성검증)</a:t>
+            </a:r>
+          </a:p>
+        </p:txBody>
+      </p:sp>
+      <p:cxnSp>
+        <p:nvCxnSpPr>
+          <p:cNvPr id="18" name="Connector 17"/>
+          <p:cNvCxnSpPr/>
+          <p:nvPr/>
+        </p:nvCxnSpPr>
+        <p:spPr>
+          <a:xfrm>
+            <a:off x="6012180" y="4389120"/>
+            <a:ext cx="137160" cy="0"/>
+          </a:xfrm>
+          <a:prstGeom prst="line">
+            <a:avLst/>
+          </a:prstGeom>
+          <a:ln w="19050">
+            <a:solidFill>
+              <a:srgbClr val="90A4AE"/>
+            </a:solidFill>
+          </a:ln>
+        </p:spPr>
+        <p:style>
+          <a:lnRef idx="2">
+            <a:schemeClr val="accent1"/>
+          </a:lnRef>
+          <a:fillRef idx="0">
+            <a:schemeClr val="accent1"/>
+          </a:fillRef>
+          <a:effectRef idx="1">
+            <a:schemeClr val="accent1"/>
+          </a:effectRef>
+          <a:fontRef idx="minor">
+            <a:schemeClr val="tx1"/>
+          </a:fontRef>
+        </p:style>
+      </p:cxnSp>
+      <p:sp>
+        <p:nvSpPr>
+          <p:cNvPr id="19" name="Rounded Rectangle 18"/>
+          <p:cNvSpPr/>
+          <p:nvPr/>
+        </p:nvSpPr>
+        <p:spPr>
+          <a:xfrm>
+            <a:off x="6149340" y="3291840"/>
+            <a:ext cx="1760220" cy="2194560"/>
+          </a:xfrm>
+          <a:prstGeom prst="roundRect">
+            <a:avLst/>
+          </a:prstGeom>
+          <a:solidFill>
+            <a:srgbClr val="E8F5E9"/>
+          </a:solidFill>
+          <a:ln w="25400">
+            <a:solidFill>
+              <a:srgbClr val="2E7D32"/>
+            </a:solidFill>
+          </a:ln>
+          <a:effectLst/>
+        </p:spPr>
+        <p:style>
+          <a:lnRef idx="1">
+            <a:schemeClr val="accent1"/>
+          </a:lnRef>
+          <a:fillRef idx="3">
+            <a:schemeClr val="accent1"/>
+          </a:fillRef>
+          <a:effectRef idx="2">
+            <a:schemeClr val="accent1"/>
+          </a:effectRef>
+          <a:fontRef idx="minor">
+            <a:schemeClr val="lt1"/>
+          </a:fontRef>
+        </p:style>
+        <p:txBody>
+          <a:bodyPr rtlCol="0" anchor="ctr" wrap="square" tIns="73152" bIns="73152"/>
+          <a:lstStyle/>
+          <a:p>
+            <a:pPr algn="ctr"/>
+            <a:r>
+              <a:rPr sz="900" b="1">
+                <a:solidFill>
+                  <a:srgbClr val="1B5E20"/>
+                </a:solidFill>
+                <a:latin typeface="Malgun Gothic"/>
+              </a:rPr>
+              <a:t>✅ 완료</a:t>
+            </a:r>
+          </a:p>
+          <a:p>
+            <a:pPr algn="ctr"/>
+            <a:r>
+              <a:rPr sz="1100" b="1">
+                <a:solidFill>
+                  <a:srgbClr val="1B5E20"/>
+                </a:solidFill>
+                <a:latin typeface="Malgun Gothic"/>
+              </a:rPr>
+              <a:t>십자(crosshair) 제거 (frame)</a:t>
+            </a:r>
+          </a:p>
+          <a:p>
+            <a:pPr algn="ctr"/>
+            <a:r>
+              <a:rPr sz="800" b="0">
+                <a:solidFill>
+                  <a:srgbClr val="1B5E20"/>
+                </a:solidFill>
+                <a:latin typeface="Malgun Gothic"/>
+              </a:rPr>
+              <a:t>십자 검출→위치를 정답으로 기록→inpaint, 재검출+edge밀도로 제거 이중 검증 (합성검증)</a:t>
+            </a:r>
+          </a:p>
+        </p:txBody>
+      </p:sp>
+      <p:cxnSp>
+        <p:nvCxnSpPr>
+          <p:cNvPr id="20" name="Connector 19"/>
+          <p:cNvCxnSpPr/>
+          <p:nvPr/>
+        </p:nvCxnSpPr>
+        <p:spPr>
+          <a:xfrm>
+            <a:off x="7909560" y="4389120"/>
+            <a:ext cx="137160" cy="0"/>
+          </a:xfrm>
+          <a:prstGeom prst="line">
+            <a:avLst/>
+          </a:prstGeom>
+          <a:ln w="19050">
+            <a:solidFill>
+              <a:srgbClr val="90A4AE"/>
+            </a:solidFill>
+          </a:ln>
+        </p:spPr>
+        <p:style>
+          <a:lnRef idx="2">
+            <a:schemeClr val="accent1"/>
+          </a:lnRef>
+          <a:fillRef idx="0">
+            <a:schemeClr val="accent1"/>
+          </a:fillRef>
+          <a:effectRef idx="1">
+            <a:schemeClr val="accent1"/>
+          </a:effectRef>
+          <a:fontRef idx="minor">
+            <a:schemeClr val="tx1"/>
+          </a:fontRef>
+        </p:style>
+      </p:cxnSp>
+      <p:sp>
+        <p:nvSpPr>
+          <p:cNvPr id="21" name="Rounded Rectangle 20"/>
+          <p:cNvSpPr/>
+          <p:nvPr/>
+        </p:nvSpPr>
+        <p:spPr>
+          <a:xfrm>
+            <a:off x="8046720" y="3291840"/>
             <a:ext cx="1760220" cy="2194560"/>
           </a:xfrm>
           <a:prstGeom prst="roundRect">
@@ -4024,7 +4252,7 @@
                 </a:solidFill>
                 <a:latin typeface="Malgun Gothic"/>
               </a:rPr>
-              <a:t>Cursor Click 감지</a:t>
+              <a:t>Align Point 정확도 검증</a:t>
             </a:r>
           </a:p>
           <a:p>
@@ -4036,20 +4264,20 @@
                 </a:solidFill>
                 <a:latin typeface="Malgun Gothic"/>
               </a:rPr>
-              <a:t>DVR / RCS / RCS-on-SEM-Monitor 3가지 cursor 변형 대응 중</a:t>
-            </a:r>
-          </a:p>
-        </p:txBody>
-      </p:sp>
-      <p:sp>
-        <p:nvSpPr>
-          <p:cNvPr id="18" name="Rounded Rectangle 17"/>
+              <a:t>2×2 비교(박스·십자 정리 효과 분리) + S전용 위치추정 검증(1발 명중률), 오피스 데이터 대기</a:t>
+            </a:r>
+          </a:p>
+        </p:txBody>
+      </p:sp>
+      <p:sp>
+        <p:nvSpPr>
+          <p:cNvPr id="22" name="Rounded Rectangle 21"/>
           <p:cNvSpPr/>
           <p:nvPr/>
         </p:nvSpPr>
         <p:spPr>
           <a:xfrm>
-            <a:off x="4674870" y="3163824"/>
+            <a:off x="8469630" y="3163824"/>
             <a:ext cx="914400" cy="256032"/>
           </a:xfrm>
           <a:prstGeom prst="roundRect">
@@ -4096,13 +4324,13 @@
       </p:sp>
       <p:cxnSp>
         <p:nvCxnSpPr>
-          <p:cNvPr id="19" name="Connector 18"/>
+          <p:cNvPr id="23" name="Connector 22"/>
           <p:cNvCxnSpPr/>
           <p:nvPr/>
         </p:nvCxnSpPr>
         <p:spPr>
           <a:xfrm>
-            <a:off x="6012180" y="4389120"/>
+            <a:off x="9806940" y="4389120"/>
             <a:ext cx="137160" cy="0"/>
           </a:xfrm>
           <a:prstGeom prst="line">
@@ -4131,180 +4359,13 @@
       </p:cxnSp>
       <p:sp>
         <p:nvSpPr>
-          <p:cNvPr id="20" name="Rounded Rectangle 19"/>
+          <p:cNvPr id="24" name="Rounded Rectangle 23"/>
           <p:cNvSpPr/>
           <p:nvPr/>
         </p:nvSpPr>
         <p:spPr>
           <a:xfrm>
-            <a:off x="6149340" y="3291840"/>
-            <a:ext cx="1760220" cy="2194560"/>
-          </a:xfrm>
-          <a:prstGeom prst="roundRect">
-            <a:avLst/>
-          </a:prstGeom>
-          <a:solidFill>
-            <a:srgbClr val="FFF3E0"/>
-          </a:solidFill>
-          <a:ln w="25400">
-            <a:solidFill>
-              <a:srgbClr val="ED6C02"/>
-            </a:solidFill>
-          </a:ln>
-          <a:effectLst/>
-        </p:spPr>
-        <p:style>
-          <a:lnRef idx="1">
-            <a:schemeClr val="accent1"/>
-          </a:lnRef>
-          <a:fillRef idx="3">
-            <a:schemeClr val="accent1"/>
-          </a:fillRef>
-          <a:effectRef idx="2">
-            <a:schemeClr val="accent1"/>
-          </a:effectRef>
-          <a:fontRef idx="minor">
-            <a:schemeClr val="lt1"/>
-          </a:fontRef>
-        </p:style>
-        <p:txBody>
-          <a:bodyPr rtlCol="0" anchor="ctr" wrap="square" tIns="73152" bIns="73152"/>
-          <a:lstStyle/>
-          <a:p>
-            <a:pPr algn="ctr"/>
-            <a:r>
-              <a:rPr sz="900" b="1">
-                <a:solidFill>
-                  <a:srgbClr val="B25500"/>
-                </a:solidFill>
-                <a:latin typeface="Malgun Gothic"/>
-              </a:rPr>
-              <a:t>🔄 진행 중</a:t>
-            </a:r>
-          </a:p>
-          <a:p>
-            <a:pPr algn="ctr"/>
-            <a:r>
-              <a:rPr sz="1100" b="1">
-                <a:solidFill>
-                  <a:srgbClr val="B25500"/>
-                </a:solidFill>
-                <a:latin typeface="Malgun Gothic"/>
-              </a:rPr>
-              <a:t>Recipe Align Key 추출 → VLM</a:t>
-            </a:r>
-          </a:p>
-          <a:p>
-            <a:pPr algn="ctr"/>
-            <a:r>
-              <a:rPr sz="800" b="0">
-                <a:solidFill>
-                  <a:srgbClr val="B25500"/>
-                </a:solidFill>
-                <a:latin typeface="Malgun Gothic"/>
-              </a:rPr>
-              <a:t>Recipe 파일에서 align key 패치 추출 후 매처/VLM 입력으로 공급</a:t>
-            </a:r>
-          </a:p>
-        </p:txBody>
-      </p:sp>
-      <p:sp>
-        <p:nvSpPr>
-          <p:cNvPr id="21" name="Rounded Rectangle 20"/>
-          <p:cNvSpPr/>
-          <p:nvPr/>
-        </p:nvSpPr>
-        <p:spPr>
-          <a:xfrm>
-            <a:off x="6572250" y="3163824"/>
-            <a:ext cx="914400" cy="256032"/>
-          </a:xfrm>
-          <a:prstGeom prst="roundRect">
-            <a:avLst/>
-          </a:prstGeom>
-          <a:solidFill>
-            <a:srgbClr val="1565C0"/>
-          </a:solidFill>
-          <a:ln>
-            <a:noFill/>
-          </a:ln>
-          <a:effectLst/>
-        </p:spPr>
-        <p:style>
-          <a:lnRef idx="1">
-            <a:schemeClr val="accent1"/>
-          </a:lnRef>
-          <a:fillRef idx="3">
-            <a:schemeClr val="accent1"/>
-          </a:fillRef>
-          <a:effectRef idx="2">
-            <a:schemeClr val="accent1"/>
-          </a:effectRef>
-          <a:fontRef idx="minor">
-            <a:schemeClr val="lt1"/>
-          </a:fontRef>
-        </p:style>
-        <p:txBody>
-          <a:bodyPr rtlCol="0" anchor="ctr" lIns="0" rIns="0" tIns="0" bIns="0"/>
-          <a:lstStyle/>
-          <a:p>
-            <a:pPr algn="ctr"/>
-            <a:r>
-              <a:rPr sz="900" b="1">
-                <a:solidFill>
-                  <a:srgbClr val="FFFFFF"/>
-                </a:solidFill>
-                <a:latin typeface="Malgun Gothic"/>
-              </a:rPr>
-              <a:t>📍 현재</a:t>
-            </a:r>
-          </a:p>
-        </p:txBody>
-      </p:sp>
-      <p:cxnSp>
-        <p:nvCxnSpPr>
-          <p:cNvPr id="22" name="Connector 21"/>
-          <p:cNvCxnSpPr/>
-          <p:nvPr/>
-        </p:nvCxnSpPr>
-        <p:spPr>
-          <a:xfrm>
-            <a:off x="7909560" y="4389120"/>
-            <a:ext cx="137160" cy="0"/>
-          </a:xfrm>
-          <a:prstGeom prst="line">
-            <a:avLst/>
-          </a:prstGeom>
-          <a:ln w="19050">
-            <a:solidFill>
-              <a:srgbClr val="90A4AE"/>
-            </a:solidFill>
-          </a:ln>
-        </p:spPr>
-        <p:style>
-          <a:lnRef idx="2">
-            <a:schemeClr val="accent1"/>
-          </a:lnRef>
-          <a:fillRef idx="0">
-            <a:schemeClr val="accent1"/>
-          </a:fillRef>
-          <a:effectRef idx="1">
-            <a:schemeClr val="accent1"/>
-          </a:effectRef>
-          <a:fontRef idx="minor">
-            <a:schemeClr val="tx1"/>
-          </a:fontRef>
-        </p:style>
-      </p:cxnSp>
-      <p:sp>
-        <p:nvSpPr>
-          <p:cNvPr id="23" name="Rounded Rectangle 22"/>
-          <p:cNvSpPr/>
-          <p:nvPr/>
-        </p:nvSpPr>
-        <p:spPr>
-          <a:xfrm>
-            <a:off x="8046720" y="3291840"/>
+            <a:off x="9944100" y="3291840"/>
             <a:ext cx="1760220" cy="2194560"/>
           </a:xfrm>
           <a:prstGeom prst="roundRect">
@@ -4358,7 +4419,7 @@
                 </a:solidFill>
                 <a:latin typeface="Malgun Gothic"/>
               </a:rPr>
-              <a:t>Align Key 매칭 (Chamfer + ORB)</a:t>
+              <a:t>실장비 FOV Search Loop</a:t>
             </a:r>
           </a:p>
           <a:p>
@@ -4370,128 +4431,14 @@
                 </a:solidFill>
                 <a:latin typeface="Malgun Gothic"/>
               </a:rPr>
-              <a:t>Recipe Align Key 추출 선행 필요, 합성 데이터 사전 검증도 미진행 (알고리즘 구현만 완료)</a:t>
-            </a:r>
-          </a:p>
-        </p:txBody>
-      </p:sp>
-      <p:cxnSp>
-        <p:nvCxnSpPr>
-          <p:cNvPr id="24" name="Connector 23"/>
-          <p:cNvCxnSpPr/>
-          <p:nvPr/>
-        </p:nvCxnSpPr>
-        <p:spPr>
-          <a:xfrm>
-            <a:off x="9806940" y="4389120"/>
-            <a:ext cx="137160" cy="0"/>
-          </a:xfrm>
-          <a:prstGeom prst="line">
-            <a:avLst/>
-          </a:prstGeom>
-          <a:ln w="19050">
-            <a:solidFill>
-              <a:srgbClr val="90A4AE"/>
-            </a:solidFill>
-          </a:ln>
-        </p:spPr>
-        <p:style>
-          <a:lnRef idx="2">
-            <a:schemeClr val="accent1"/>
-          </a:lnRef>
-          <a:fillRef idx="0">
-            <a:schemeClr val="accent1"/>
-          </a:fillRef>
-          <a:effectRef idx="1">
-            <a:schemeClr val="accent1"/>
-          </a:effectRef>
-          <a:fontRef idx="minor">
-            <a:schemeClr val="tx1"/>
-          </a:fontRef>
-        </p:style>
-      </p:cxnSp>
-      <p:sp>
-        <p:nvSpPr>
-          <p:cNvPr id="25" name="Rounded Rectangle 24"/>
-          <p:cNvSpPr/>
-          <p:nvPr/>
-        </p:nvSpPr>
-        <p:spPr>
-          <a:xfrm>
-            <a:off x="9944100" y="3291840"/>
-            <a:ext cx="1760220" cy="2194560"/>
-          </a:xfrm>
-          <a:prstGeom prst="roundRect">
-            <a:avLst/>
-          </a:prstGeom>
-          <a:solidFill>
-            <a:srgbClr val="F5F5F5"/>
-          </a:solidFill>
-          <a:ln w="25400">
-            <a:solidFill>
-              <a:srgbClr val="757575"/>
-            </a:solidFill>
-          </a:ln>
-          <a:effectLst/>
-        </p:spPr>
-        <p:style>
-          <a:lnRef idx="1">
-            <a:schemeClr val="accent1"/>
-          </a:lnRef>
-          <a:fillRef idx="3">
-            <a:schemeClr val="accent1"/>
-          </a:fillRef>
-          <a:effectRef idx="2">
-            <a:schemeClr val="accent1"/>
-          </a:effectRef>
-          <a:fontRef idx="minor">
-            <a:schemeClr val="lt1"/>
-          </a:fontRef>
-        </p:style>
-        <p:txBody>
-          <a:bodyPr rtlCol="0" anchor="ctr" wrap="square" tIns="73152" bIns="73152"/>
-          <a:lstStyle/>
-          <a:p>
-            <a:pPr algn="ctr"/>
-            <a:r>
-              <a:rPr sz="900" b="1">
-                <a:solidFill>
-                  <a:srgbClr val="424242"/>
-                </a:solidFill>
-                <a:latin typeface="Malgun Gothic"/>
-              </a:rPr>
-              <a:t>⏳ 대기</a:t>
-            </a:r>
-          </a:p>
-          <a:p>
-            <a:pPr algn="ctr"/>
-            <a:r>
-              <a:rPr sz="1100" b="1">
-                <a:solidFill>
-                  <a:srgbClr val="424242"/>
-                </a:solidFill>
-                <a:latin typeface="Malgun Gothic"/>
-              </a:rPr>
-              <a:t>FOV Search Loop</a:t>
-            </a:r>
-          </a:p>
-          <a:p>
-            <a:pPr algn="ctr"/>
-            <a:r>
-              <a:rPr sz="800" b="0">
-                <a:solidFill>
-                  <a:srgbClr val="424242"/>
-                </a:solidFill>
-                <a:latin typeface="Malgun Gothic"/>
-              </a:rPr>
-              <a:t>매처 결과로 stage 이동·escalation, 실 SEM 환경 검증 필요</a:t>
-            </a:r>
-          </a:p>
-        </p:txBody>
-      </p:sp>
-      <p:sp>
-        <p:nvSpPr>
-          <p:cNvPr id="26" name="Rectangle 25"/>
+              <a:t>검증 통과 후 실 SEM 연결 어댑터·안전장치 구현 → 매처 결과로 stage 이동</a:t>
+            </a:r>
+          </a:p>
+        </p:txBody>
+      </p:sp>
+      <p:sp>
+        <p:nvSpPr>
+          <p:cNvPr id="25" name="Rectangle 24"/>
           <p:cNvSpPr/>
           <p:nvPr/>
         </p:nvSpPr>
@@ -4537,7 +4484,7 @@
       </p:sp>
       <p:sp>
         <p:nvSpPr>
-          <p:cNvPr id="27" name="TextBox 26"/>
+          <p:cNvPr id="26" name="TextBox 25"/>
           <p:cNvSpPr txBox="1"/>
           <p:nvPr/>
         </p:nvSpPr>
@@ -4572,7 +4519,7 @@
       </p:sp>
       <p:sp>
         <p:nvSpPr>
-          <p:cNvPr id="28" name="Rectangle 27"/>
+          <p:cNvPr id="27" name="Rectangle 26"/>
           <p:cNvSpPr/>
           <p:nvPr/>
         </p:nvSpPr>
@@ -4618,7 +4565,7 @@
       </p:sp>
       <p:sp>
         <p:nvSpPr>
-          <p:cNvPr id="29" name="TextBox 28"/>
+          <p:cNvPr id="28" name="TextBox 27"/>
           <p:cNvSpPr txBox="1"/>
           <p:nvPr/>
         </p:nvSpPr>
@@ -4653,7 +4600,7 @@
       </p:sp>
       <p:sp>
         <p:nvSpPr>
-          <p:cNvPr id="30" name="Rectangle 29"/>
+          <p:cNvPr id="29" name="Rectangle 28"/>
           <p:cNvSpPr/>
           <p:nvPr/>
         </p:nvSpPr>
@@ -4699,7 +4646,7 @@
       </p:sp>
       <p:sp>
         <p:nvSpPr>
-          <p:cNvPr id="31" name="TextBox 30"/>
+          <p:cNvPr id="30" name="TextBox 29"/>
           <p:cNvSpPr txBox="1"/>
           <p:nvPr/>
         </p:nvSpPr>
@@ -4975,7 +4922,7 @@
                           </a:solidFill>
                           <a:latin typeface="Malgun Gothic"/>
                         </a:rPr>
-                        <a:t>Frame 변화 필터링 (CV)</a:t>
+                        <a:t>SEM 화면 영역 검출</a:t>
                       </a:r>
                     </a:p>
                   </a:txBody>
@@ -5021,7 +4968,7 @@
                           </a:solidFill>
                           <a:latin typeface="Malgun Gothic"/>
                         </a:rPr>
-                        <a:t>cv2.absdiff·dilate·connectedComponents로 정적 프레임 제거, VLM 입력량 축소</a:t>
+                        <a:t>모든 탐색의 기준점인 live SEM 박스를 검출, 장비별 기준 위치 저장</a:t>
                       </a:r>
                     </a:p>
                   </a:txBody>
@@ -5069,7 +5016,7 @@
                           </a:solidFill>
                           <a:latin typeface="Malgun Gothic"/>
                         </a:rPr>
-                        <a:t>SEM Monitor Box 인식</a:t>
+                        <a:t>OK 버튼 검출·클릭</a:t>
                       </a:r>
                     </a:p>
                   </a:txBody>
@@ -5115,7 +5062,7 @@
                           </a:solidFill>
                           <a:latin typeface="Malgun Gothic"/>
                         </a:rPr>
-                        <a:t>VLM이 live SEM 영역 bbox를 식별 (제어 패널 가림에도 정상 동작)</a:t>
+                        <a:t>보정을 확정하는 마지막 동작, OCR 재확인으로 오클릭 차단</a:t>
                       </a:r>
                     </a:p>
                   </a:txBody>
@@ -5146,6 +5093,194 @@
                   </a:txBody>
                   <a:tcPr>
                     <a:solidFill>
+                      <a:srgbClr val="FFFFFF"/>
+                    </a:solidFill>
+                  </a:tcPr>
+                </a:tc>
+                <a:tc>
+                  <a:txBody>
+                    <a:bodyPr wrap="square" lIns="73152" rIns="73152" tIns="54864" bIns="54864" anchor="ctr"/>
+                    <a:lstStyle/>
+                    <a:p>
+                      <a:pPr algn="l"/>
+                      <a:r>
+                        <a:rPr sz="1200" b="1">
+                          <a:solidFill>
+                            <a:srgbClr val="212121"/>
+                          </a:solidFill>
+                          <a:latin typeface="Malgun Gothic"/>
+                        </a:rPr>
+                        <a:t>흰 박스 제거 (template)</a:t>
+                      </a:r>
+                    </a:p>
+                  </a:txBody>
+                  <a:tcPr>
+                    <a:solidFill>
+                      <a:srgbClr val="FFFFFF"/>
+                    </a:solidFill>
+                  </a:tcPr>
+                </a:tc>
+                <a:tc>
+                  <a:txBody>
+                    <a:bodyPr wrap="square" lIns="73152" rIns="73152" tIns="54864" bIns="54864" anchor="ctr"/>
+                    <a:lstStyle/>
+                    <a:p>
+                      <a:pPr algn="ctr"/>
+                      <a:r>
+                        <a:rPr sz="1100" b="1">
+                          <a:solidFill>
+                            <a:srgbClr val="1B5E20"/>
+                          </a:solidFill>
+                          <a:latin typeface="Malgun Gothic"/>
+                        </a:rPr>
+                        <a:t>✅ 완료</a:t>
+                      </a:r>
+                    </a:p>
+                  </a:txBody>
+                  <a:tcPr>
+                    <a:solidFill>
+                      <a:srgbClr val="FFFFFF"/>
+                    </a:solidFill>
+                  </a:tcPr>
+                </a:tc>
+                <a:tc>
+                  <a:txBody>
+                    <a:bodyPr wrap="square" lIns="73152" rIns="73152" tIns="54864" bIns="54864" anchor="ctr"/>
+                    <a:lstStyle/>
+                    <a:p>
+                      <a:pPr algn="l"/>
+                      <a:r>
+                        <a:rPr sz="1100" b="0">
+                          <a:solidFill>
+                            <a:srgbClr val="424242"/>
+                          </a:solidFill>
+                          <a:latin typeface="Malgun Gothic"/>
+                        </a:rPr>
+                        <a:t>고정 디지털값(히스토그램 섬) photometric 검출로 박스 안쪽만 crop, 최악 샘플 1/6→6/6 (합성검증)</a:t>
+                      </a:r>
+                    </a:p>
+                  </a:txBody>
+                  <a:tcPr>
+                    <a:solidFill>
+                      <a:srgbClr val="FFFFFF"/>
+                    </a:solidFill>
+                  </a:tcPr>
+                </a:tc>
+              </a:tr>
+              <a:tr h="705394">
+                <a:tc>
+                  <a:txBody>
+                    <a:bodyPr wrap="square" lIns="73152" rIns="73152" tIns="54864" bIns="54864" anchor="ctr"/>
+                    <a:lstStyle/>
+                    <a:p>
+                      <a:pPr algn="ctr"/>
+                      <a:r>
+                        <a:rPr sz="1100" b="0">
+                          <a:solidFill>
+                            <a:srgbClr val="616161"/>
+                          </a:solidFill>
+                          <a:latin typeface="Malgun Gothic"/>
+                        </a:rPr>
+                        <a:t>4</a:t>
+                      </a:r>
+                    </a:p>
+                  </a:txBody>
+                  <a:tcPr>
+                    <a:solidFill>
+                      <a:srgbClr val="FAFAFA"/>
+                    </a:solidFill>
+                  </a:tcPr>
+                </a:tc>
+                <a:tc>
+                  <a:txBody>
+                    <a:bodyPr wrap="square" lIns="73152" rIns="73152" tIns="54864" bIns="54864" anchor="ctr"/>
+                    <a:lstStyle/>
+                    <a:p>
+                      <a:pPr algn="l"/>
+                      <a:r>
+                        <a:rPr sz="1200" b="1">
+                          <a:solidFill>
+                            <a:srgbClr val="212121"/>
+                          </a:solidFill>
+                          <a:latin typeface="Malgun Gothic"/>
+                        </a:rPr>
+                        <a:t>십자(crosshair) 제거 (frame)</a:t>
+                      </a:r>
+                    </a:p>
+                  </a:txBody>
+                  <a:tcPr>
+                    <a:solidFill>
+                      <a:srgbClr val="FAFAFA"/>
+                    </a:solidFill>
+                  </a:tcPr>
+                </a:tc>
+                <a:tc>
+                  <a:txBody>
+                    <a:bodyPr wrap="square" lIns="73152" rIns="73152" tIns="54864" bIns="54864" anchor="ctr"/>
+                    <a:lstStyle/>
+                    <a:p>
+                      <a:pPr algn="ctr"/>
+                      <a:r>
+                        <a:rPr sz="1100" b="1">
+                          <a:solidFill>
+                            <a:srgbClr val="1B5E20"/>
+                          </a:solidFill>
+                          <a:latin typeface="Malgun Gothic"/>
+                        </a:rPr>
+                        <a:t>✅ 완료</a:t>
+                      </a:r>
+                    </a:p>
+                  </a:txBody>
+                  <a:tcPr>
+                    <a:solidFill>
+                      <a:srgbClr val="FAFAFA"/>
+                    </a:solidFill>
+                  </a:tcPr>
+                </a:tc>
+                <a:tc>
+                  <a:txBody>
+                    <a:bodyPr wrap="square" lIns="73152" rIns="73152" tIns="54864" bIns="54864" anchor="ctr"/>
+                    <a:lstStyle/>
+                    <a:p>
+                      <a:pPr algn="l"/>
+                      <a:r>
+                        <a:rPr sz="1100" b="0">
+                          <a:solidFill>
+                            <a:srgbClr val="424242"/>
+                          </a:solidFill>
+                          <a:latin typeface="Malgun Gothic"/>
+                        </a:rPr>
+                        <a:t>십자 검출→위치를 정답으로 기록→inpaint, 재검출+edge밀도로 제거 이중 검증 (합성검증)</a:t>
+                      </a:r>
+                    </a:p>
+                  </a:txBody>
+                  <a:tcPr>
+                    <a:solidFill>
+                      <a:srgbClr val="FAFAFA"/>
+                    </a:solidFill>
+                  </a:tcPr>
+                </a:tc>
+              </a:tr>
+              <a:tr h="705394">
+                <a:tc>
+                  <a:txBody>
+                    <a:bodyPr wrap="square" lIns="73152" rIns="73152" tIns="54864" bIns="54864" anchor="ctr"/>
+                    <a:lstStyle/>
+                    <a:p>
+                      <a:pPr algn="ctr"/>
+                      <a:r>
+                        <a:rPr sz="1100" b="0">
+                          <a:solidFill>
+                            <a:srgbClr val="616161"/>
+                          </a:solidFill>
+                          <a:latin typeface="Malgun Gothic"/>
+                        </a:rPr>
+                        <a:t>5</a:t>
+                      </a:r>
+                    </a:p>
+                  </a:txBody>
+                  <a:tcPr>
+                    <a:solidFill>
                       <a:srgbClr val="E3F2FD"/>
                     </a:solidFill>
                   </a:tcPr>
@@ -5163,7 +5298,7 @@
                           </a:solidFill>
                           <a:latin typeface="Malgun Gothic"/>
                         </a:rPr>
-                        <a:t>Cursor Click 감지  📍</a:t>
+                        <a:t>Align Point 정확도 검증  📍</a:t>
                       </a:r>
                     </a:p>
                   </a:txBody>
@@ -5209,201 +5344,13 @@
                           </a:solidFill>
                           <a:latin typeface="Malgun Gothic"/>
                         </a:rPr>
-                        <a:t>DVR / RCS / RCS-on-SEM-Monitor 3가지 cursor 변형 대응 중</a:t>
+                        <a:t>2×2 비교(박스·십자 정리 효과 분리) + S전용 위치추정 검증(1발 명중률), 오피스 데이터 대기</a:t>
                       </a:r>
                     </a:p>
                   </a:txBody>
                   <a:tcPr>
                     <a:solidFill>
                       <a:srgbClr val="E3F2FD"/>
-                    </a:solidFill>
-                  </a:tcPr>
-                </a:tc>
-              </a:tr>
-              <a:tr h="705394">
-                <a:tc>
-                  <a:txBody>
-                    <a:bodyPr wrap="square" lIns="73152" rIns="73152" tIns="54864" bIns="54864" anchor="ctr"/>
-                    <a:lstStyle/>
-                    <a:p>
-                      <a:pPr algn="ctr"/>
-                      <a:r>
-                        <a:rPr sz="1100" b="0">
-                          <a:solidFill>
-                            <a:srgbClr val="616161"/>
-                          </a:solidFill>
-                          <a:latin typeface="Malgun Gothic"/>
-                        </a:rPr>
-                        <a:t>4</a:t>
-                      </a:r>
-                    </a:p>
-                  </a:txBody>
-                  <a:tcPr>
-                    <a:solidFill>
-                      <a:srgbClr val="E3F2FD"/>
-                    </a:solidFill>
-                  </a:tcPr>
-                </a:tc>
-                <a:tc>
-                  <a:txBody>
-                    <a:bodyPr wrap="square" lIns="73152" rIns="73152" tIns="54864" bIns="54864" anchor="ctr"/>
-                    <a:lstStyle/>
-                    <a:p>
-                      <a:pPr algn="l"/>
-                      <a:r>
-                        <a:rPr sz="1200" b="1">
-                          <a:solidFill>
-                            <a:srgbClr val="212121"/>
-                          </a:solidFill>
-                          <a:latin typeface="Malgun Gothic"/>
-                        </a:rPr>
-                        <a:t>Recipe Align Key 추출 → VLM  📍</a:t>
-                      </a:r>
-                    </a:p>
-                  </a:txBody>
-                  <a:tcPr>
-                    <a:solidFill>
-                      <a:srgbClr val="E3F2FD"/>
-                    </a:solidFill>
-                  </a:tcPr>
-                </a:tc>
-                <a:tc>
-                  <a:txBody>
-                    <a:bodyPr wrap="square" lIns="73152" rIns="73152" tIns="54864" bIns="54864" anchor="ctr"/>
-                    <a:lstStyle/>
-                    <a:p>
-                      <a:pPr algn="ctr"/>
-                      <a:r>
-                        <a:rPr sz="1100" b="1">
-                          <a:solidFill>
-                            <a:srgbClr val="B25500"/>
-                          </a:solidFill>
-                          <a:latin typeface="Malgun Gothic"/>
-                        </a:rPr>
-                        <a:t>🔄 진행 중</a:t>
-                      </a:r>
-                    </a:p>
-                  </a:txBody>
-                  <a:tcPr>
-                    <a:solidFill>
-                      <a:srgbClr val="E3F2FD"/>
-                    </a:solidFill>
-                  </a:tcPr>
-                </a:tc>
-                <a:tc>
-                  <a:txBody>
-                    <a:bodyPr wrap="square" lIns="73152" rIns="73152" tIns="54864" bIns="54864" anchor="ctr"/>
-                    <a:lstStyle/>
-                    <a:p>
-                      <a:pPr algn="l"/>
-                      <a:r>
-                        <a:rPr sz="1100" b="0">
-                          <a:solidFill>
-                            <a:srgbClr val="424242"/>
-                          </a:solidFill>
-                          <a:latin typeface="Malgun Gothic"/>
-                        </a:rPr>
-                        <a:t>Recipe 파일에서 align key 패치 추출 후 매처/VLM 입력으로 공급</a:t>
-                      </a:r>
-                    </a:p>
-                  </a:txBody>
-                  <a:tcPr>
-                    <a:solidFill>
-                      <a:srgbClr val="E3F2FD"/>
-                    </a:solidFill>
-                  </a:tcPr>
-                </a:tc>
-              </a:tr>
-              <a:tr h="705394">
-                <a:tc>
-                  <a:txBody>
-                    <a:bodyPr wrap="square" lIns="73152" rIns="73152" tIns="54864" bIns="54864" anchor="ctr"/>
-                    <a:lstStyle/>
-                    <a:p>
-                      <a:pPr algn="ctr"/>
-                      <a:r>
-                        <a:rPr sz="1100" b="0">
-                          <a:solidFill>
-                            <a:srgbClr val="616161"/>
-                          </a:solidFill>
-                          <a:latin typeface="Malgun Gothic"/>
-                        </a:rPr>
-                        <a:t>5</a:t>
-                      </a:r>
-                    </a:p>
-                  </a:txBody>
-                  <a:tcPr>
-                    <a:solidFill>
-                      <a:srgbClr val="FFFFFF"/>
-                    </a:solidFill>
-                  </a:tcPr>
-                </a:tc>
-                <a:tc>
-                  <a:txBody>
-                    <a:bodyPr wrap="square" lIns="73152" rIns="73152" tIns="54864" bIns="54864" anchor="ctr"/>
-                    <a:lstStyle/>
-                    <a:p>
-                      <a:pPr algn="l"/>
-                      <a:r>
-                        <a:rPr sz="1200" b="1">
-                          <a:solidFill>
-                            <a:srgbClr val="212121"/>
-                          </a:solidFill>
-                          <a:latin typeface="Malgun Gothic"/>
-                        </a:rPr>
-                        <a:t>Align Key 매칭 (Chamfer + ORB)</a:t>
-                      </a:r>
-                    </a:p>
-                  </a:txBody>
-                  <a:tcPr>
-                    <a:solidFill>
-                      <a:srgbClr val="FFFFFF"/>
-                    </a:solidFill>
-                  </a:tcPr>
-                </a:tc>
-                <a:tc>
-                  <a:txBody>
-                    <a:bodyPr wrap="square" lIns="73152" rIns="73152" tIns="54864" bIns="54864" anchor="ctr"/>
-                    <a:lstStyle/>
-                    <a:p>
-                      <a:pPr algn="ctr"/>
-                      <a:r>
-                        <a:rPr sz="1100" b="1">
-                          <a:solidFill>
-                            <a:srgbClr val="424242"/>
-                          </a:solidFill>
-                          <a:latin typeface="Malgun Gothic"/>
-                        </a:rPr>
-                        <a:t>⏳ 대기</a:t>
-                      </a:r>
-                    </a:p>
-                  </a:txBody>
-                  <a:tcPr>
-                    <a:solidFill>
-                      <a:srgbClr val="FFFFFF"/>
-                    </a:solidFill>
-                  </a:tcPr>
-                </a:tc>
-                <a:tc>
-                  <a:txBody>
-                    <a:bodyPr wrap="square" lIns="73152" rIns="73152" tIns="54864" bIns="54864" anchor="ctr"/>
-                    <a:lstStyle/>
-                    <a:p>
-                      <a:pPr algn="l"/>
-                      <a:r>
-                        <a:rPr sz="1100" b="0">
-                          <a:solidFill>
-                            <a:srgbClr val="424242"/>
-                          </a:solidFill>
-                          <a:latin typeface="Malgun Gothic"/>
-                        </a:rPr>
-                        <a:t>Recipe Align Key 추출 선행 필요, 합성 데이터 사전 검증도 미진행 (알고리즘 구현만 완료)</a:t>
-                      </a:r>
-                    </a:p>
-                  </a:txBody>
-                  <a:tcPr>
-                    <a:solidFill>
-                      <a:srgbClr val="FFFFFF"/>
                     </a:solidFill>
                   </a:tcPr>
                 </a:tc>
@@ -5445,7 +5392,7 @@
                           </a:solidFill>
                           <a:latin typeface="Malgun Gothic"/>
                         </a:rPr>
-                        <a:t>FOV Search Loop</a:t>
+                        <a:t>실장비 FOV Search Loop</a:t>
                       </a:r>
                     </a:p>
                   </a:txBody>
@@ -5491,7 +5438,7 @@
                           </a:solidFill>
                           <a:latin typeface="Malgun Gothic"/>
                         </a:rPr>
-                        <a:t>매처 결과로 stage 이동·escalation, 실 SEM 환경 검증 필요</a:t>
+                        <a:t>검증 통과 후 실 SEM 연결 어댑터·안전장치 구현 → 매처 결과로 stage 이동</a:t>
                       </a:r>
                     </a:p>
                   </a:txBody>
@@ -5628,7 +5575,7 @@
                 </a:solidFill>
                 <a:latin typeface="Malgun Gothic"/>
               </a:rPr>
-              <a:t>1. Cursor Click 감지의 환경/위치 변형 대응 마무리 후 실 RCS 회귀 테스트</a:t>
+              <a:t>1. (오피스) 골든셋 수집 — 성공(S) 측정 이미지를 recipe당 8~10장, 웨이퍼/lot/시간 분산</a:t>
             </a:r>
           </a:p>
           <a:p>
@@ -5644,7 +5591,7 @@
                 </a:solidFill>
                 <a:latin typeface="Malgun Gothic"/>
               </a:rPr>
-              <a:t>2. Recipe Align Key 이미지 추출 파이프라인 코어 구현 및 VLM 입력 검증</a:t>
+              <a:t>2. 정답 위생 먼저 확인 — 십자 검출률이 낮으면 그 위 수치 신뢰 불가, 검출기부터 점검</a:t>
             </a:r>
           </a:p>
           <a:p>
@@ -5660,7 +5607,7 @@
                 </a:solidFill>
                 <a:latin typeface="Malgun Gothic"/>
               </a:rPr>
-              <a:t>3. Align Key 매칭(Chamfer+ORB) 합성 데이터 사전 검증부터 시작 → 실데이터 calibration (positive/negative 50+ pairs로 임계값 검증)</a:t>
+              <a:t>3. 본 판정 — golden_localization_eval.py 로 NEW(박스+inpaint)의 1발 명중률을 OLD 대비 측정, 통과 시 정식 채택</a:t>
             </a:r>
           </a:p>
           <a:p>
@@ -5676,7 +5623,23 @@
                 </a:solidFill>
                 <a:latin typeface="Malgun Gothic"/>
               </a:rPr>
-              <a:t>4. FOV Search Loop 통합 → 매니저 라이브 데모 준비</a:t>
+              <a:t>4. 임계 캘리브레이션 — success_vs_fail_compare.py 로 거짓양성 0 검증 후 fail 데이터 적용</a:t>
+            </a:r>
+          </a:p>
+          <a:p>
+            <a:pPr algn="l">
+              <a:spcAft>
+                <a:spcPts val="1200"/>
+              </a:spcAft>
+            </a:pPr>
+            <a:r>
+              <a:rPr sz="1800" b="0">
+                <a:solidFill>
+                  <a:srgbClr val="263238"/>
+                </a:solidFill>
+                <a:latin typeface="Malgun Gothic"/>
+              </a:rPr>
+              <a:t>5. 잔여 실패율로 VLM+CV 백업(gated escalation) 필요량 판단 → 필요시에만 구축</a:t>
             </a:r>
           </a:p>
         </p:txBody>

</xml_diff>